<commit_message>
Advance PPTX viewer fidelity: masters, SoftCanvas images, text
Resolve theme → master → layout → slide into a concrete scene before EVG,
blit PNG/JPEG via SoftCanvas, and improve text align/size/wrap/insets.
Add fixtures 11–20 (incl. business deck), wire LibreOffice + python-pptx
oracles, and preserve DrawingML a:t leading spaces in the XML parser.

Co-authored-by: Tero <terotests@users.noreply.github.com>
</commit_message>
<xml_diff>
--- a/gallery/pptx/fixtures/01-text.pptx
+++ b/gallery/pptx/fixtures/01-text.pptx
@@ -115,7 +115,7 @@
                 </a:solidFill>
                 <a:latin typeface="Calibri"/>
               </a:rPr>
-              <a:t>Hello from PowerPoint</a:t>
+              <a:t xml:space="preserve">Hello from PowerPoint</a:t>
             </a:r>
           </a:p>
         </p:txBody>
@@ -148,7 +148,7 @@
                 </a:solidFill>
                 <a:latin typeface="Calibri"/>
               </a:rPr>
-              <a:t>Ranger PPTX Lite viewer</a:t>
+              <a:t xml:space="preserve">Ranger PPTX Lite viewer</a:t>
             </a:r>
           </a:p>
         </p:txBody>

</xml_diff>